<commit_message>
Add recorded narration and timings to risks slides
</commit_message>
<xml_diff>
--- a/presentation/AI_Coding_Agents_Risks_Final.pptx
+++ b/presentation/AI_Coding_Agents_Risks_Final.pptx
@@ -110,6 +110,11 @@
       </a:defRPr>
     </a:lvl9pPr>
   </p:defaultTextStyle>
+  <p:extLst>
+    <p:ext uri="{EFAFB233-063F-42B5-8137-9DF3F51BA10A}">
+      <p15:sldGuideLst xmlns:p15="http://schemas.microsoft.com/office/powerpoint/2012/main"/>
+    </p:ext>
+  </p:extLst>
 </p:presentation>
 </file>
 
@@ -195,7 +200,7 @@
           <a:p>
             <a:fld id="{C1F035F1-07FA-410F-821F-62A9ADE87369}" type="datetimeFigureOut">
               <a:rPr lang="en-CA" smtClean="0"/>
-              <a:t>2026-10-17</a:t>
+              <a:t>2026-10-18</a:t>
             </a:fld>
             <a:endParaRPr lang="en-CA"/>
           </a:p>
@@ -1207,7 +1212,7 @@
           <a:p>
             <a:fld id="{531E18A8-734C-404C-8681-DBF7765A2615}" type="datetimeFigureOut">
               <a:rPr lang="en-CA" smtClean="0"/>
-              <a:t>2026-10-17</a:t>
+              <a:t>2026-10-18</a:t>
             </a:fld>
             <a:endParaRPr lang="en-CA"/>
           </a:p>
@@ -1407,7 +1412,7 @@
           <a:p>
             <a:fld id="{531E18A8-734C-404C-8681-DBF7765A2615}" type="datetimeFigureOut">
               <a:rPr lang="en-CA" smtClean="0"/>
-              <a:t>2026-10-17</a:t>
+              <a:t>2026-10-18</a:t>
             </a:fld>
             <a:endParaRPr lang="en-CA"/>
           </a:p>
@@ -1617,7 +1622,7 @@
           <a:p>
             <a:fld id="{531E18A8-734C-404C-8681-DBF7765A2615}" type="datetimeFigureOut">
               <a:rPr lang="en-CA" smtClean="0"/>
-              <a:t>2026-10-17</a:t>
+              <a:t>2026-10-18</a:t>
             </a:fld>
             <a:endParaRPr lang="en-CA"/>
           </a:p>
@@ -1817,7 +1822,7 @@
           <a:p>
             <a:fld id="{531E18A8-734C-404C-8681-DBF7765A2615}" type="datetimeFigureOut">
               <a:rPr lang="en-CA" smtClean="0"/>
-              <a:t>2026-10-17</a:t>
+              <a:t>2026-10-18</a:t>
             </a:fld>
             <a:endParaRPr lang="en-CA"/>
           </a:p>
@@ -2093,7 +2098,7 @@
           <a:p>
             <a:fld id="{531E18A8-734C-404C-8681-DBF7765A2615}" type="datetimeFigureOut">
               <a:rPr lang="en-CA" smtClean="0"/>
-              <a:t>2026-10-17</a:t>
+              <a:t>2026-10-18</a:t>
             </a:fld>
             <a:endParaRPr lang="en-CA"/>
           </a:p>
@@ -2361,7 +2366,7 @@
           <a:p>
             <a:fld id="{531E18A8-734C-404C-8681-DBF7765A2615}" type="datetimeFigureOut">
               <a:rPr lang="en-CA" smtClean="0"/>
-              <a:t>2026-10-17</a:t>
+              <a:t>2026-10-18</a:t>
             </a:fld>
             <a:endParaRPr lang="en-CA"/>
           </a:p>
@@ -2776,7 +2781,7 @@
           <a:p>
             <a:fld id="{531E18A8-734C-404C-8681-DBF7765A2615}" type="datetimeFigureOut">
               <a:rPr lang="en-CA" smtClean="0"/>
-              <a:t>2026-10-17</a:t>
+              <a:t>2026-10-18</a:t>
             </a:fld>
             <a:endParaRPr lang="en-CA"/>
           </a:p>
@@ -2918,7 +2923,7 @@
           <a:p>
             <a:fld id="{531E18A8-734C-404C-8681-DBF7765A2615}" type="datetimeFigureOut">
               <a:rPr lang="en-CA" smtClean="0"/>
-              <a:t>2026-10-17</a:t>
+              <a:t>2026-10-18</a:t>
             </a:fld>
             <a:endParaRPr lang="en-CA"/>
           </a:p>
@@ -3031,7 +3036,7 @@
           <a:p>
             <a:fld id="{531E18A8-734C-404C-8681-DBF7765A2615}" type="datetimeFigureOut">
               <a:rPr lang="en-CA" smtClean="0"/>
-              <a:t>2026-10-17</a:t>
+              <a:t>2026-10-18</a:t>
             </a:fld>
             <a:endParaRPr lang="en-CA"/>
           </a:p>
@@ -3344,7 +3349,7 @@
           <a:p>
             <a:fld id="{531E18A8-734C-404C-8681-DBF7765A2615}" type="datetimeFigureOut">
               <a:rPr lang="en-CA" smtClean="0"/>
-              <a:t>2026-10-17</a:t>
+              <a:t>2026-10-18</a:t>
             </a:fld>
             <a:endParaRPr lang="en-CA"/>
           </a:p>
@@ -3633,7 +3638,7 @@
           <a:p>
             <a:fld id="{531E18A8-734C-404C-8681-DBF7765A2615}" type="datetimeFigureOut">
               <a:rPr lang="en-CA" smtClean="0"/>
-              <a:t>2026-10-17</a:t>
+              <a:t>2026-10-18</a:t>
             </a:fld>
             <a:endParaRPr lang="en-CA"/>
           </a:p>
@@ -3876,7 +3881,7 @@
           <a:p>
             <a:fld id="{531E18A8-734C-404C-8681-DBF7765A2615}" type="datetimeFigureOut">
               <a:rPr lang="en-CA" smtClean="0"/>
-              <a:t>2026-10-17</a:t>
+              <a:t>2026-10-18</a:t>
             </a:fld>
             <a:endParaRPr lang="en-CA"/>
           </a:p>
@@ -4471,7 +4476,7 @@
           <a:blip>
             <a:extLst>
               <a:ext uri="{96DAC541-7B7A-43D3-8B79-37D633B846F1}">
-                <asvg:svgBlip xmlns:asvg="http://schemas.microsoft.com/office/drawing/2016/SVG/main" r:embed="rId3"/>
+                <asvg:svgBlip xmlns:asvg="http://schemas.microsoft.com/office/drawing/2016/SVG/main" r:embed="rId5"/>
               </a:ext>
             </a:extLst>
           </a:blip>
@@ -4661,7 +4666,7 @@
           <a:blip>
             <a:extLst>
               <a:ext uri="{96DAC541-7B7A-43D3-8B79-37D633B846F1}">
-                <asvg:svgBlip xmlns:asvg="http://schemas.microsoft.com/office/drawing/2016/SVG/main" r:embed="rId4"/>
+                <asvg:svgBlip xmlns:asvg="http://schemas.microsoft.com/office/drawing/2016/SVG/main" r:embed="rId6"/>
               </a:ext>
             </a:extLst>
           </a:blip>
@@ -4851,7 +4856,7 @@
           <a:blip>
             <a:extLst>
               <a:ext uri="{96DAC541-7B7A-43D3-8B79-37D633B846F1}">
-                <asvg:svgBlip xmlns:asvg="http://schemas.microsoft.com/office/drawing/2016/SVG/main" r:embed="rId5"/>
+                <asvg:svgBlip xmlns:asvg="http://schemas.microsoft.com/office/drawing/2016/SVG/main" r:embed="rId7"/>
               </a:ext>
             </a:extLst>
           </a:blip>
@@ -5098,6 +5103,44 @@
           </a:p>
         </p:txBody>
       </p:sp>
+      <p:pic>
+        <p:nvPicPr>
+          <p:cNvPr id="2" name="Sebastian_Risks_Voiceover">
+            <a:hlinkClick r:id="" action="ppaction://media"/>
+            <a:extLst>
+              <a:ext uri="{FF2B5EF4-FFF2-40B4-BE49-F238E27FC236}">
+                <a16:creationId xmlns:a16="http://schemas.microsoft.com/office/drawing/2014/main" id="{D3C0F7C9-2C94-7610-6B57-DFDA8CA58BE9}"/>
+              </a:ext>
+            </a:extLst>
+          </p:cNvPr>
+          <p:cNvPicPr>
+            <a:picLocks noChangeAspect="1"/>
+          </p:cNvPicPr>
+          <p:nvPr>
+            <a:audioFile r:link="rId2"/>
+            <p:extLst>
+              <p:ext uri="{DAA4B4D4-6D71-4841-9C94-3DE7FCFB9230}">
+                <p14:media xmlns:p14="http://schemas.microsoft.com/office/powerpoint/2010/main" r:embed="rId1"/>
+              </p:ext>
+            </p:extLst>
+          </p:nvPr>
+        </p:nvPicPr>
+        <p:blipFill>
+          <a:blip r:embed="rId8"/>
+          <a:stretch>
+            <a:fillRect/>
+          </a:stretch>
+        </p:blipFill>
+        <p:spPr>
+          <a:xfrm>
+            <a:off x="11211664" y="6109136"/>
+            <a:ext cx="487363" cy="487363"/>
+          </a:xfrm>
+          <a:prstGeom prst="rect">
+            <a:avLst/>
+          </a:prstGeom>
+        </p:spPr>
+      </p:pic>
     </p:spTree>
     <p:extLst>
       <p:ext uri="{BB962C8B-B14F-4D97-AF65-F5344CB8AC3E}">
@@ -5108,6 +5151,111 @@
   <p:clrMapOvr>
     <a:masterClrMapping/>
   </p:clrMapOvr>
+  <mc:AlternateContent xmlns:mc="http://schemas.openxmlformats.org/markup-compatibility/2006">
+    <mc:Choice xmlns:p14="http://schemas.microsoft.com/office/powerpoint/2010/main" Requires="p14">
+      <p:transition spd="slow" p14:dur="2000" advTm="19306"/>
+    </mc:Choice>
+    <mc:Fallback>
+      <p:transition spd="slow" advTm="19306"/>
+    </mc:Fallback>
+  </mc:AlternateContent>
+  <p:timing>
+    <p:tnLst>
+      <p:par>
+        <p:cTn id="1" dur="indefinite" restart="never" nodeType="tmRoot">
+          <p:childTnLst>
+            <p:seq concurrent="1" nextAc="seek">
+              <p:cTn id="2" dur="indefinite" nodeType="mainSeq">
+                <p:childTnLst>
+                  <p:par>
+                    <p:cTn id="3" fill="hold">
+                      <p:stCondLst>
+                        <p:cond delay="indefinite"/>
+                        <p:cond evt="onBegin" delay="0">
+                          <p:tn val="2"/>
+                        </p:cond>
+                      </p:stCondLst>
+                      <p:childTnLst>
+                        <p:par>
+                          <p:cTn id="4" fill="hold">
+                            <p:stCondLst>
+                              <p:cond delay="0"/>
+                            </p:stCondLst>
+                            <p:childTnLst>
+                              <p:par>
+                                <p:cTn id="5" presetID="1" presetClass="mediacall" presetSubtype="0" fill="hold" nodeType="afterEffect">
+                                  <p:stCondLst>
+                                    <p:cond delay="0"/>
+                                  </p:stCondLst>
+                                  <p:childTnLst>
+                                    <p:cmd type="call" cmd="playFrom(0.0)">
+                                      <p:cBhvr>
+                                        <p:cTn id="6" dur="1" fill="hold"/>
+                                        <p:tgtEl>
+                                          <p:spTgt spid="2"/>
+                                        </p:tgtEl>
+                                      </p:cBhvr>
+                                    </p:cmd>
+                                  </p:childTnLst>
+                                </p:cTn>
+                              </p:par>
+                            </p:childTnLst>
+                          </p:cTn>
+                        </p:par>
+                      </p:childTnLst>
+                    </p:cTn>
+                  </p:par>
+                </p:childTnLst>
+              </p:cTn>
+              <p:prevCondLst>
+                <p:cond evt="onPrev" delay="0">
+                  <p:tgtEl>
+                    <p:sldTgt/>
+                  </p:tgtEl>
+                </p:cond>
+              </p:prevCondLst>
+              <p:nextCondLst>
+                <p:cond evt="onNext" delay="0">
+                  <p:tgtEl>
+                    <p:sldTgt/>
+                  </p:tgtEl>
+                </p:cond>
+              </p:nextCondLst>
+            </p:seq>
+            <p:audio>
+              <p:cMediaNode vol="80000" numSld="999" showWhenStopped="0">
+                <p:cTn id="7" fill="hold" display="0">
+                  <p:stCondLst>
+                    <p:cond delay="indefinite"/>
+                  </p:stCondLst>
+                  <p:endCondLst>
+                    <p:cond evt="onStopAudio" delay="0">
+                      <p:tgtEl>
+                        <p:sldTgt/>
+                      </p:tgtEl>
+                    </p:cond>
+                  </p:endCondLst>
+                </p:cTn>
+                <p:tgtEl>
+                  <p:spTgt spid="2"/>
+                </p:tgtEl>
+              </p:cMediaNode>
+            </p:audio>
+          </p:childTnLst>
+        </p:cTn>
+      </p:par>
+    </p:tnLst>
+  </p:timing>
+  <p:extLst>
+    <p:ext uri="{E180D4A7-C9FB-4DFB-919C-405C955672EB}">
+      <p14:showEvtLst xmlns:p14="http://schemas.microsoft.com/office/powerpoint/2010/main">
+        <p14:playEvt time="0" objId="2"/>
+        <p14:pauseEvt time="1470" objId="2"/>
+        <p14:seekEvt time="1471" objId="2" seek="1442"/>
+        <p14:resumeEvt time="1471" objId="2"/>
+      </p14:showEvtLst>
+    </p:ext>
+  </p:extLst>
 </p:sld>
 </file>
 
@@ -6107,6 +6255,14 @@
   <p:clrMapOvr>
     <a:masterClrMapping/>
   </p:clrMapOvr>
+  <mc:AlternateContent xmlns:mc="http://schemas.openxmlformats.org/markup-compatibility/2006">
+    <mc:Choice xmlns:p14="http://schemas.microsoft.com/office/powerpoint/2010/main" Requires="p14">
+      <p:transition spd="slow" p14:dur="2000" advTm="39677"/>
+    </mc:Choice>
+    <mc:Fallback>
+      <p:transition spd="slow" advTm="39677"/>
+    </mc:Fallback>
+  </mc:AlternateContent>
 </p:sld>
 </file>
 
@@ -6680,6 +6836,14 @@
   <p:clrMapOvr>
     <a:masterClrMapping/>
   </p:clrMapOvr>
+  <mc:AlternateContent xmlns:mc="http://schemas.openxmlformats.org/markup-compatibility/2006">
+    <mc:Choice xmlns:p14="http://schemas.microsoft.com/office/powerpoint/2010/main" Requires="p14">
+      <p:transition spd="slow" p14:dur="2000" advTm="37399"/>
+    </mc:Choice>
+    <mc:Fallback>
+      <p:transition spd="slow" advTm="37399"/>
+    </mc:Fallback>
+  </mc:AlternateContent>
 </p:sld>
 </file>
 

</xml_diff>